<commit_message>
fix(presentation): update first slide SIH logo with official vertical emblem
</commit_message>
<xml_diff>
--- a/SIH2026_IDEA_Presentation_SIH26102.pptx
+++ b/SIH2026_IDEA_Presentation_SIH26102.pptx
@@ -3118,8 +3118,8 @@
         </p:blipFill>
         <p:spPr>
           <a:xfrm>
-            <a:off x="10789920" y="182880"/>
-            <a:ext cx="914400" cy="1508760"/>
+            <a:off x="9875520" y="164592"/>
+            <a:ext cx="1920240" cy="891752"/>
           </a:xfrm>
           <a:prstGeom prst="rect">
             <a:avLst/>
@@ -3214,8 +3214,8 @@
         </p:blipFill>
         <p:spPr>
           <a:xfrm>
-            <a:off x="7132320" y="1554480"/>
-            <a:ext cx="4206240" cy="4206240"/>
+            <a:off x="7863840" y="1645920"/>
+            <a:ext cx="3091586" cy="4480560"/>
           </a:xfrm>
           <a:prstGeom prst="rect">
             <a:avLst/>
@@ -3641,8 +3641,8 @@
         </p:blipFill>
         <p:spPr>
           <a:xfrm>
-            <a:off x="10881360" y="109728"/>
-            <a:ext cx="868680" cy="1371600"/>
+            <a:off x="9875520" y="164592"/>
+            <a:ext cx="1920240" cy="891752"/>
           </a:xfrm>
           <a:prstGeom prst="rect">
             <a:avLst/>
@@ -4527,8 +4527,8 @@
         </p:blipFill>
         <p:spPr>
           <a:xfrm>
-            <a:off x="10881360" y="109728"/>
-            <a:ext cx="868680" cy="1371600"/>
+            <a:off x="9875520" y="164592"/>
+            <a:ext cx="1920240" cy="891752"/>
           </a:xfrm>
           <a:prstGeom prst="rect">
             <a:avLst/>
@@ -4992,8 +4992,8 @@
         </p:blipFill>
         <p:spPr>
           <a:xfrm>
-            <a:off x="10881360" y="109728"/>
-            <a:ext cx="868680" cy="1371600"/>
+            <a:off x="9875520" y="164592"/>
+            <a:ext cx="1920240" cy="891752"/>
           </a:xfrm>
           <a:prstGeom prst="rect">
             <a:avLst/>
@@ -5529,8 +5529,8 @@
         </p:blipFill>
         <p:spPr>
           <a:xfrm>
-            <a:off x="10881360" y="109728"/>
-            <a:ext cx="868680" cy="1371600"/>
+            <a:off x="9875520" y="164592"/>
+            <a:ext cx="1920240" cy="891752"/>
           </a:xfrm>
           <a:prstGeom prst="rect">
             <a:avLst/>
@@ -6018,8 +6018,8 @@
         </p:blipFill>
         <p:spPr>
           <a:xfrm>
-            <a:off x="10881360" y="109728"/>
-            <a:ext cx="868680" cy="1371600"/>
+            <a:off x="9875520" y="164592"/>
+            <a:ext cx="1920240" cy="891752"/>
           </a:xfrm>
           <a:prstGeom prst="rect">
             <a:avLst/>
@@ -7872,8 +7872,8 @@
         </p:blipFill>
         <p:spPr>
           <a:xfrm>
-            <a:off x="10881360" y="109728"/>
-            <a:ext cx="868680" cy="1371600"/>
+            <a:off x="9875520" y="164592"/>
+            <a:ext cx="1920240" cy="891752"/>
           </a:xfrm>
           <a:prstGeom prst="rect">
             <a:avLst/>

</xml_diff>